<commit_message>
pequena mudança adicionando o slide de fim
</commit_message>
<xml_diff>
--- a/apresentação_FINAL/CARMESIM QUEST - FINAL.pptx
+++ b/apresentação_FINAL/CARMESIM QUEST - FINAL.pptx
@@ -18,6 +18,7 @@
     <p:sldId id="310" r:id="rId12"/>
     <p:sldId id="309" r:id="rId13"/>
     <p:sldId id="285" r:id="rId14"/>
+    <p:sldId id="311" r:id="rId15"/>
   </p:sldIdLst>
   <p:sldSz cx="12192000" cy="6858000"/>
   <p:notesSz cx="6858000" cy="9144000"/>
@@ -134,6 +135,7 @@
             <p14:sldId id="310"/>
             <p14:sldId id="309"/>
             <p14:sldId id="285"/>
+            <p14:sldId id="311"/>
           </p14:sldIdLst>
         </p14:section>
       </p14:sectionLst>
@@ -3809,6 +3811,79 @@
     <p:extLst>
       <p:ext uri="{BB962C8B-B14F-4D97-AF65-F5344CB8AC3E}">
         <p14:creationId xmlns:p14="http://schemas.microsoft.com/office/powerpoint/2010/main" val="2706361080"/>
+      </p:ext>
+    </p:extLst>
+  </p:cSld>
+  <p:clrMapOvr>
+    <a:overrideClrMapping bg1="lt1" tx1="dk1" bg2="lt2" tx2="dk2" accent1="accent1" accent2="accent2" accent3="accent3" accent4="accent4" accent5="accent5" accent6="accent6" hlink="hlink" folHlink="folHlink"/>
+  </p:clrMapOvr>
+</p:sld>
+</file>
+
+<file path=ppt/slides/slide14.xml><?xml version="1.0" encoding="utf-8"?>
+<p:sld xmlns:a="http://schemas.openxmlformats.org/drawingml/2006/main" xmlns:r="http://schemas.openxmlformats.org/officeDocument/2006/relationships" xmlns:p="http://schemas.openxmlformats.org/presentationml/2006/main">
+  <p:cSld>
+    <p:bg>
+      <p:bgPr>
+        <a:solidFill>
+          <a:srgbClr val="FF0000"/>
+        </a:solidFill>
+        <a:effectLst/>
+      </p:bgPr>
+    </p:bg>
+    <p:spTree>
+      <p:nvGrpSpPr>
+        <p:cNvPr id="1" name=""/>
+        <p:cNvGrpSpPr/>
+        <p:nvPr/>
+      </p:nvGrpSpPr>
+      <p:grpSpPr>
+        <a:xfrm>
+          <a:off x="0" y="0"/>
+          <a:ext cx="0" cy="0"/>
+          <a:chOff x="0" y="0"/>
+          <a:chExt cx="0" cy="0"/>
+        </a:xfrm>
+      </p:grpSpPr>
+      <p:sp>
+        <p:nvSpPr>
+          <p:cNvPr id="2" name="Título 1">
+            <a:extLst>
+              <a:ext uri="{FF2B5EF4-FFF2-40B4-BE49-F238E27FC236}">
+                <a16:creationId xmlns:a16="http://schemas.microsoft.com/office/drawing/2014/main" id="{755DA167-1BBF-D5BB-514A-3F47B37C32A2}"/>
+              </a:ext>
+            </a:extLst>
+          </p:cNvPr>
+          <p:cNvSpPr>
+            <a:spLocks noGrp="1"/>
+          </p:cNvSpPr>
+          <p:nvPr>
+            <p:ph type="title"/>
+          </p:nvPr>
+        </p:nvSpPr>
+        <p:spPr>
+          <a:xfrm>
+            <a:off x="838200" y="2766218"/>
+            <a:ext cx="10515600" cy="1325563"/>
+          </a:xfrm>
+        </p:spPr>
+        <p:txBody>
+          <a:bodyPr>
+            <a:normAutofit/>
+          </a:bodyPr>
+          <a:lstStyle/>
+          <a:p>
+            <a:r>
+              <a:rPr lang="pt-BR" sz="8000" b="1" dirty="0"/>
+              <a:t>FIM</a:t>
+            </a:r>
+          </a:p>
+        </p:txBody>
+      </p:sp>
+    </p:spTree>
+    <p:extLst>
+      <p:ext uri="{BB962C8B-B14F-4D97-AF65-F5344CB8AC3E}">
+        <p14:creationId xmlns:p14="http://schemas.microsoft.com/office/powerpoint/2010/main" val="1077692774"/>
       </p:ext>
     </p:extLst>
   </p:cSld>
@@ -5182,6 +5257,49 @@
 </a:themeOverride>
 </file>
 
+<file path=ppt/theme/themeOverride13.xml><?xml version="1.0" encoding="utf-8"?>
+<a:themeOverride xmlns:a="http://schemas.openxmlformats.org/drawingml/2006/main">
+  <a:clrScheme name="Laranja Vermelho">
+    <a:dk1>
+      <a:sysClr val="windowText" lastClr="000000"/>
+    </a:dk1>
+    <a:lt1>
+      <a:sysClr val="window" lastClr="FFFFFF"/>
+    </a:lt1>
+    <a:dk2>
+      <a:srgbClr val="505046"/>
+    </a:dk2>
+    <a:lt2>
+      <a:srgbClr val="EEECE1"/>
+    </a:lt2>
+    <a:accent1>
+      <a:srgbClr val="E84C22"/>
+    </a:accent1>
+    <a:accent2>
+      <a:srgbClr val="FFBD47"/>
+    </a:accent2>
+    <a:accent3>
+      <a:srgbClr val="B64926"/>
+    </a:accent3>
+    <a:accent4>
+      <a:srgbClr val="FF8427"/>
+    </a:accent4>
+    <a:accent5>
+      <a:srgbClr val="CC9900"/>
+    </a:accent5>
+    <a:accent6>
+      <a:srgbClr val="B22600"/>
+    </a:accent6>
+    <a:hlink>
+      <a:srgbClr val="CC9900"/>
+    </a:hlink>
+    <a:folHlink>
+      <a:srgbClr val="666699"/>
+    </a:folHlink>
+  </a:clrScheme>
+</a:themeOverride>
+</file>
+
 <file path=ppt/theme/themeOverride2.xml><?xml version="1.0" encoding="utf-8"?>
 <a:themeOverride xmlns:a="http://schemas.openxmlformats.org/drawingml/2006/main">
   <a:clrScheme name="Laranja Vermelho">

</xml_diff>